<commit_message>
Commit prior-session BRICK-Mengel ext artifacts (catch-up)
Sweeps up uncommitted prior-session work that the post-2018 extension handoff
references but that was never committed:
- calibrate_mcmc_ext.jl: prefer ext-tuned adapted_cov_ext.csv as proposal seed
  (falls back to baseline cov, then diagonal) -- per handoff section 5.
- recalib inputs/targets (recalib_targets.csv, recalib_central_row.csv,
  param_priors.csv, recalib_knobs.csv, target_sigmas.csv) and central trajectories.
- per-seed MCMC adapted-cov + logs (outputs/mcmc/).
- SSP-2100 projections + ensemble timeseries/summaries.
- AIS/GSIC H1/H2 diagnostics, oceantemp sweeps, full-joint calib, Mengel glacier
  param fits, per-SSP FaIR-mean GMST/OHC forcing CSVs, updated slides.

Co-Authored-By: Claude Opus 4.8 <noreply@anthropic.com>
</commit_message>
<xml_diff>
--- a/outputs/SLR_extraslides.pptx
+++ b/outputs/SLR_extraslides.pptx
@@ -8,6 +8,7 @@
     <p:sldId id="256" r:id="rId2"/>
     <p:sldId id="257" r:id="rId3"/>
     <p:sldId id="258" r:id="rId4"/>
+    <p:sldId id="259" r:id="rId5"/>
   </p:sldIdLst>
   <p:sldSz cx="12192000" cy="6858000"/>
   <p:notesSz cx="6858000" cy="9144000"/>
@@ -3509,6 +3510,96 @@
 </p:sld>
 </file>
 
+<file path=ppt/slides/slide4.xml><?xml version="1.0" encoding="utf-8"?>
+<p:sld xmlns:a="http://schemas.openxmlformats.org/drawingml/2006/main" xmlns:r="http://schemas.openxmlformats.org/officeDocument/2006/relationships" xmlns:p="http://schemas.openxmlformats.org/presentationml/2006/main">
+  <p:cSld>
+    <p:spTree>
+      <p:nvGrpSpPr>
+        <p:cNvPr id="1" name=""/>
+        <p:cNvGrpSpPr/>
+        <p:nvPr/>
+      </p:nvGrpSpPr>
+      <p:grpSpPr>
+        <a:xfrm>
+          <a:off x="0" y="0"/>
+          <a:ext cx="0" cy="0"/>
+          <a:chOff x="0" y="0"/>
+          <a:chExt cx="0" cy="0"/>
+        </a:xfrm>
+      </p:grpSpPr>
+      <p:pic>
+        <p:nvPicPr>
+          <p:cNvPr id="4" name="Picture 3">
+            <a:extLst>
+              <a:ext uri="{FF2B5EF4-FFF2-40B4-BE49-F238E27FC236}">
+                <a16:creationId xmlns:a16="http://schemas.microsoft.com/office/drawing/2014/main" id="{F070A008-E557-8A1B-9E72-833A37BDF9EF}"/>
+              </a:ext>
+            </a:extLst>
+          </p:cNvPr>
+          <p:cNvPicPr>
+            <a:picLocks noChangeAspect="1"/>
+          </p:cNvPicPr>
+          <p:nvPr/>
+        </p:nvPicPr>
+        <p:blipFill>
+          <a:blip r:embed="rId2"/>
+          <a:stretch>
+            <a:fillRect/>
+          </a:stretch>
+        </p:blipFill>
+        <p:spPr>
+          <a:xfrm>
+            <a:off x="0" y="0"/>
+            <a:ext cx="6858000" cy="3429000"/>
+          </a:xfrm>
+          <a:prstGeom prst="rect">
+            <a:avLst/>
+          </a:prstGeom>
+        </p:spPr>
+      </p:pic>
+      <p:pic>
+        <p:nvPicPr>
+          <p:cNvPr id="6" name="Picture 5">
+            <a:extLst>
+              <a:ext uri="{FF2B5EF4-FFF2-40B4-BE49-F238E27FC236}">
+                <a16:creationId xmlns:a16="http://schemas.microsoft.com/office/drawing/2014/main" id="{5EDE87A2-6E6F-7C1B-384A-91633769E096}"/>
+              </a:ext>
+            </a:extLst>
+          </p:cNvPr>
+          <p:cNvPicPr>
+            <a:picLocks noChangeAspect="1"/>
+          </p:cNvPicPr>
+          <p:nvPr/>
+        </p:nvPicPr>
+        <p:blipFill>
+          <a:blip r:embed="rId3"/>
+          <a:stretch>
+            <a:fillRect/>
+          </a:stretch>
+        </p:blipFill>
+        <p:spPr>
+          <a:xfrm>
+            <a:off x="5184057" y="3118755"/>
+            <a:ext cx="6948949" cy="3474475"/>
+          </a:xfrm>
+          <a:prstGeom prst="rect">
+            <a:avLst/>
+          </a:prstGeom>
+        </p:spPr>
+      </p:pic>
+    </p:spTree>
+    <p:extLst>
+      <p:ext uri="{BB962C8B-B14F-4D97-AF65-F5344CB8AC3E}">
+        <p14:creationId xmlns:p14="http://schemas.microsoft.com/office/powerpoint/2010/main" val="480381354"/>
+      </p:ext>
+    </p:extLst>
+  </p:cSld>
+  <p:clrMapOvr>
+    <a:masterClrMapping/>
+  </p:clrMapOvr>
+</p:sld>
+</file>
+
 <file path=ppt/theme/theme1.xml><?xml version="1.0" encoding="utf-8"?>
 <a:theme xmlns:a="http://schemas.openxmlformats.org/drawingml/2006/main" name="Office Theme">
   <a:themeElements>

</xml_diff>